<commit_message>
Modo de atuação só no PM&GO integrado
Suporte/Controle/Diretivo é a intensidade da Obliant numa governança
integrada — não faz sentido para recomendações de EPP, GMO, EPP+GMO
apartados ou suporte leve.

- Site: a faixa de modo só é renderizada quando a recomendação é PM&GO;
  demais saídas exibem oferta + por quê + eixos, sem modo. Dossiê idem.
- Deck: nota do modo corrigida para 'exclusivo do PM&GO integrado'.

Co-Authored-By: Claude Fable 5 <noreply@anthropic.com>
Claude-Session: https://claude.ai/code/session_01L3Uyz73ytmRz13GDoXb629
</commit_message>
<xml_diff>
--- a/Metodologia_Obliant.pptx
+++ b/Metodologia_Obliant.pptx
@@ -23575,7 +23575,7 @@
         <p:spPr>
           <a:xfrm>
             <a:off x="548640" y="4937760"/>
-            <a:ext cx="7315200" cy="237744"/>
+            <a:ext cx="8229600" cy="237744"/>
           </a:xfrm>
           <a:prstGeom prst="rect">
             <a:avLst/>
@@ -23599,7 +23599,7 @@
                 <a:ea typeface="Inter" pitchFamily="34" charset="-122"/>
                 <a:cs typeface="Inter" pitchFamily="34" charset="-120"/>
               </a:rPr>
-              <a:t>MODO DE ATUAÇÃO (INTENSIDADE) — ortogonal à oferta</a:t>
+              <a:t>MODO DE ATUAÇÃO (INTENSIDADE) — exclusivo do PM&amp;GO integrado</a:t>
             </a:r>
             <a:endParaRPr lang="en-US" sz="900" dirty="0"/>
           </a:p>

</xml_diff>

<commit_message>
Fit do PM&GO como portão: sem output combinado EPP+GMO
O assessment do PM&GO é um teste de fit para o PM&GO — não um roteador
de ofertas combinadas. EPP, GMO e PM&GO são produtos distintos.

- Há fit (A,B,C altos) -> recomenda PM&GO + modo (Suporte/Controle/Diretivo)
- Sem fit -> aponta UMA frente a avaliar: EPP ou GMO (a predominante),
  ou suporte leve quando nada é crítico; nunca 'EPP + GMO' juntos
- Resultado liderado por veredito 'Há/Sem fit para o PM&GO' + atalho
  'Avaliar maturidade EPP/GMO'
- Carteira, dossiê, card 'Como lemos', aba PM&GO e deck atualizados;
  compatível com diagnósticos já salvos (deriva fit de rec)

Co-Authored-By: Claude Fable 5 <noreply@anthropic.com>
Claude-Session: https://claude.ai/code/session_01L3Uyz73ytmRz13GDoXb629
</commit_message>
<xml_diff>
--- a/Metodologia_Obliant.pptx
+++ b/Metodologia_Obliant.pptx
@@ -22408,7 +22408,7 @@
                 <a:ea typeface="Fraunces" pitchFamily="34" charset="-122"/>
                 <a:cs typeface="Fraunces" pitchFamily="34" charset="-120"/>
               </a:rPr>
-              <a:t>Assessment de fit — três eixos, oferta e modo certos</a:t>
+              <a:t>Assessment de fit — há fit para o PM&amp;GO?</a:t>
             </a:r>
             <a:endParaRPr lang="en-US" sz="2600" dirty="0"/>
           </a:p>
@@ -22447,7 +22447,7 @@
                 <a:ea typeface="Inter" pitchFamily="34" charset="-122"/>
                 <a:cs typeface="Inter" pitchFamily="34" charset="-120"/>
               </a:rPr>
-              <a:t>Para o PM&amp;GO o assessment mede adequação (fit), não maturidade: 8 perguntas em três eixos — A (necessidade de entrega), B (necessidade de adoção) e C (interdependência e criticidade). O resultado recomenda a oferta certa — só EPP, só GMO, EPP + GMO apartados, PM&amp;GO integrado ou suporte leve — e o modo de atuação.</a:t>
+              <a:t>Este assessment é um portão de fit para o PM&amp;GO: 8 perguntas em três eixos — A (necessidade de entrega), B (necessidade de adoção) e C (interdependência e criticidade). Se houver fit, recomenda o PM&amp;GO e o modo de atuação (Suporte, Controle ou Diretivo). Se não houver, aponta uma frente a avaliar — EPP ou GMO — ou suporte leve.</a:t>
             </a:r>
             <a:endParaRPr lang="en-US" sz="1100" dirty="0"/>
           </a:p>
@@ -22996,7 +22996,7 @@
                 <a:ea typeface="Inter" pitchFamily="34" charset="-122"/>
                 <a:cs typeface="Inter" pitchFamily="34" charset="-120"/>
               </a:rPr>
-              <a:t>O eixo C (interdependência + criticidade) separa PM&amp;GO integrado de EPP + GMO apartados.</a:t>
+              <a:t>Há fit para o PM&amp;GO só quando A, B e C são altos. Sem fit, avalia-se UMA frente — EPP ou GMO — nunca as duas juntas.</a:t>
             </a:r>
             <a:endParaRPr lang="en-US" sz="900" dirty="0"/>
           </a:p>
@@ -23011,7 +23011,7 @@
         <p:spPr>
           <a:xfrm>
             <a:off x="548640" y="3657600"/>
-            <a:ext cx="3657600" cy="237744"/>
+            <a:ext cx="4572000" cy="237744"/>
           </a:xfrm>
           <a:prstGeom prst="rect">
             <a:avLst/>
@@ -23035,7 +23035,7 @@
                 <a:ea typeface="Inter" pitchFamily="34" charset="-122"/>
                 <a:cs typeface="Inter" pitchFamily="34" charset="-120"/>
               </a:rPr>
-              <a:t>RECOMENDAÇÃO</a:t>
+              <a:t>SAÍDAS DO PORTÃO DE FIT</a:t>
             </a:r>
             <a:endParaRPr lang="en-US" sz="900" dirty="0"/>
           </a:p>
@@ -23050,6 +23050,111 @@
         <p:spPr>
           <a:xfrm>
             <a:off x="548640" y="3931920"/>
+            <a:ext cx="2115922" cy="841248"/>
+          </a:xfrm>
+          <a:prstGeom prst="roundRect">
+            <a:avLst>
+              <a:gd name="adj" fmla="val 6522"/>
+            </a:avLst>
+          </a:prstGeom>
+          <a:solidFill>
+            <a:srgbClr val="4A5C72"/>
+          </a:solidFill>
+          <a:ln w="9525">
+            <a:solidFill>
+              <a:srgbClr val="4A5C72"/>
+            </a:solidFill>
+            <a:prstDash val="solid"/>
+          </a:ln>
+        </p:spPr>
+      </p:sp>
+      <p:sp>
+        <p:nvSpPr>
+          <p:cNvPr id="20" name="Text 18"/>
+          <p:cNvSpPr/>
+          <p:nvPr/>
+        </p:nvSpPr>
+        <p:spPr>
+          <a:xfrm>
+            <a:off x="658368" y="4023360"/>
+            <a:ext cx="1896466" cy="329184"/>
+          </a:xfrm>
+          <a:prstGeom prst="rect">
+            <a:avLst/>
+          </a:prstGeom>
+          <a:noFill/>
+          <a:ln/>
+        </p:spPr>
+        <p:txBody>
+          <a:bodyPr wrap="square" rtlCol="0" anchor="t"/>
+          <a:lstStyle/>
+          <a:p>
+            <a:pPr indent="0" marL="0">
+              <a:buNone/>
+            </a:pPr>
+            <a:r>
+              <a:rPr lang="en-US" sz="750" dirty="0">
+                <a:solidFill>
+                  <a:srgbClr val="B9C3D0"/>
+                </a:solidFill>
+                <a:latin typeface="Inter" pitchFamily="34" charset="0"/>
+                <a:ea typeface="Inter" pitchFamily="34" charset="-122"/>
+                <a:cs typeface="Inter" pitchFamily="34" charset="-120"/>
+              </a:rPr>
+              <a:t>A+B+C altas</a:t>
+            </a:r>
+            <a:endParaRPr lang="en-US" sz="750" dirty="0"/>
+          </a:p>
+        </p:txBody>
+      </p:sp>
+      <p:sp>
+        <p:nvSpPr>
+          <p:cNvPr id="21" name="Text 19"/>
+          <p:cNvSpPr/>
+          <p:nvPr/>
+        </p:nvSpPr>
+        <p:spPr>
+          <a:xfrm>
+            <a:off x="658368" y="4334256"/>
+            <a:ext cx="1896466" cy="384048"/>
+          </a:xfrm>
+          <a:prstGeom prst="rect">
+            <a:avLst/>
+          </a:prstGeom>
+          <a:noFill/>
+          <a:ln/>
+        </p:spPr>
+        <p:txBody>
+          <a:bodyPr wrap="square" rtlCol="0" anchor="t"/>
+          <a:lstStyle/>
+          <a:p>
+            <a:pPr indent="0" marL="0">
+              <a:buNone/>
+            </a:pPr>
+            <a:r>
+              <a:rPr lang="en-US" sz="1100" dirty="0">
+                <a:solidFill>
+                  <a:srgbClr val="FFFDF6"/>
+                </a:solidFill>
+                <a:latin typeface="Fraunces" pitchFamily="34" charset="0"/>
+                <a:ea typeface="Fraunces" pitchFamily="34" charset="-122"/>
+                <a:cs typeface="Fraunces" pitchFamily="34" charset="-120"/>
+              </a:rPr>
+              <a:t>PM&amp;GO + modo</a:t>
+            </a:r>
+            <a:endParaRPr lang="en-US" sz="1100" dirty="0"/>
+          </a:p>
+        </p:txBody>
+      </p:sp>
+      <p:sp>
+        <p:nvSpPr>
+          <p:cNvPr id="22" name="Shape 20"/>
+          <p:cNvSpPr/>
+          <p:nvPr/>
+        </p:nvSpPr>
+        <p:spPr>
+          <a:xfrm>
+            <a:off x="2792578" y="3931920"/>
             <a:ext cx="2115922" cy="841248"/>
           </a:xfrm>
           <a:prstGeom prst="roundRect">
@@ -23070,13 +23175,13 @@
       </p:sp>
       <p:sp>
         <p:nvSpPr>
-          <p:cNvPr id="20" name="Text 18"/>
-          <p:cNvSpPr/>
-          <p:nvPr/>
-        </p:nvSpPr>
-        <p:spPr>
-          <a:xfrm>
-            <a:off x="658368" y="4023360"/>
+          <p:cNvPr id="23" name="Text 21"/>
+          <p:cNvSpPr/>
+          <p:nvPr/>
+        </p:nvSpPr>
+        <p:spPr>
+          <a:xfrm>
+            <a:off x="2902306" y="4023360"/>
             <a:ext cx="1896466" cy="329184"/>
           </a:xfrm>
           <a:prstGeom prst="rect">
@@ -23101,7 +23206,7 @@
                 <a:ea typeface="Inter" pitchFamily="34" charset="-122"/>
                 <a:cs typeface="Inter" pitchFamily="34" charset="-120"/>
               </a:rPr>
-              <a:t>A alta · B baixa</a:t>
+              <a:t>A+B altas · C baixa</a:t>
             </a:r>
             <a:endParaRPr lang="en-US" sz="750" dirty="0"/>
           </a:p>
@@ -23109,13 +23214,13 @@
       </p:sp>
       <p:sp>
         <p:nvSpPr>
-          <p:cNvPr id="21" name="Text 19"/>
-          <p:cNvSpPr/>
-          <p:nvPr/>
-        </p:nvSpPr>
-        <p:spPr>
-          <a:xfrm>
-            <a:off x="658368" y="4334256"/>
+          <p:cNvPr id="24" name="Text 22"/>
+          <p:cNvSpPr/>
+          <p:nvPr/>
+        </p:nvSpPr>
+        <p:spPr>
+          <a:xfrm>
+            <a:off x="2902306" y="4334256"/>
             <a:ext cx="1896466" cy="384048"/>
           </a:xfrm>
           <a:prstGeom prst="rect">
@@ -23140,7 +23245,7 @@
                 <a:ea typeface="Fraunces" pitchFamily="34" charset="-122"/>
                 <a:cs typeface="Fraunces" pitchFamily="34" charset="-120"/>
               </a:rPr>
-              <a:t>Só EPP</a:t>
+              <a:t>Sem fit → EPP ou GMO</a:t>
             </a:r>
             <a:endParaRPr lang="en-US" sz="1100" dirty="0"/>
           </a:p>
@@ -23148,13 +23253,13 @@
       </p:sp>
       <p:sp>
         <p:nvSpPr>
-          <p:cNvPr id="22" name="Shape 20"/>
-          <p:cNvSpPr/>
-          <p:nvPr/>
-        </p:nvSpPr>
-        <p:spPr>
-          <a:xfrm>
-            <a:off x="2792578" y="3931920"/>
+          <p:cNvPr id="25" name="Shape 23"/>
+          <p:cNvSpPr/>
+          <p:nvPr/>
+        </p:nvSpPr>
+        <p:spPr>
+          <a:xfrm>
+            <a:off x="5036515" y="3931920"/>
             <a:ext cx="2115922" cy="841248"/>
           </a:xfrm>
           <a:prstGeom prst="roundRect">
@@ -23175,13 +23280,13 @@
       </p:sp>
       <p:sp>
         <p:nvSpPr>
-          <p:cNvPr id="23" name="Text 21"/>
-          <p:cNvSpPr/>
-          <p:nvPr/>
-        </p:nvSpPr>
-        <p:spPr>
-          <a:xfrm>
-            <a:off x="2902306" y="4023360"/>
+          <p:cNvPr id="26" name="Text 24"/>
+          <p:cNvSpPr/>
+          <p:nvPr/>
+        </p:nvSpPr>
+        <p:spPr>
+          <a:xfrm>
+            <a:off x="5146243" y="4023360"/>
             <a:ext cx="1896466" cy="329184"/>
           </a:xfrm>
           <a:prstGeom prst="rect">
@@ -23206,7 +23311,7 @@
                 <a:ea typeface="Inter" pitchFamily="34" charset="-122"/>
                 <a:cs typeface="Inter" pitchFamily="34" charset="-120"/>
               </a:rPr>
-              <a:t>A baixa · B alta</a:t>
+              <a:t>A alta · B baixa</a:t>
             </a:r>
             <a:endParaRPr lang="en-US" sz="750" dirty="0"/>
           </a:p>
@@ -23214,13 +23319,13 @@
       </p:sp>
       <p:sp>
         <p:nvSpPr>
-          <p:cNvPr id="24" name="Text 22"/>
-          <p:cNvSpPr/>
-          <p:nvPr/>
-        </p:nvSpPr>
-        <p:spPr>
-          <a:xfrm>
-            <a:off x="2902306" y="4334256"/>
+          <p:cNvPr id="27" name="Text 25"/>
+          <p:cNvSpPr/>
+          <p:nvPr/>
+        </p:nvSpPr>
+        <p:spPr>
+          <a:xfrm>
+            <a:off x="5146243" y="4334256"/>
             <a:ext cx="1896466" cy="384048"/>
           </a:xfrm>
           <a:prstGeom prst="rect">
@@ -23245,7 +23350,7 @@
                 <a:ea typeface="Fraunces" pitchFamily="34" charset="-122"/>
                 <a:cs typeface="Fraunces" pitchFamily="34" charset="-120"/>
               </a:rPr>
-              <a:t>Só GMO</a:t>
+              <a:t>Sem fit → EPP</a:t>
             </a:r>
             <a:endParaRPr lang="en-US" sz="1100" dirty="0"/>
           </a:p>
@@ -23253,13 +23358,13 @@
       </p:sp>
       <p:sp>
         <p:nvSpPr>
-          <p:cNvPr id="25" name="Shape 23"/>
-          <p:cNvSpPr/>
-          <p:nvPr/>
-        </p:nvSpPr>
-        <p:spPr>
-          <a:xfrm>
-            <a:off x="5036515" y="3931920"/>
+          <p:cNvPr id="28" name="Shape 26"/>
+          <p:cNvSpPr/>
+          <p:nvPr/>
+        </p:nvSpPr>
+        <p:spPr>
+          <a:xfrm>
+            <a:off x="7280453" y="3931920"/>
             <a:ext cx="2115922" cy="841248"/>
           </a:xfrm>
           <a:prstGeom prst="roundRect">
@@ -23280,13 +23385,13 @@
       </p:sp>
       <p:sp>
         <p:nvSpPr>
-          <p:cNvPr id="26" name="Text 24"/>
-          <p:cNvSpPr/>
-          <p:nvPr/>
-        </p:nvSpPr>
-        <p:spPr>
-          <a:xfrm>
-            <a:off x="5146243" y="4023360"/>
+          <p:cNvPr id="29" name="Text 27"/>
+          <p:cNvSpPr/>
+          <p:nvPr/>
+        </p:nvSpPr>
+        <p:spPr>
+          <a:xfrm>
+            <a:off x="7390181" y="4023360"/>
             <a:ext cx="1896466" cy="329184"/>
           </a:xfrm>
           <a:prstGeom prst="rect">
@@ -23311,7 +23416,7 @@
                 <a:ea typeface="Inter" pitchFamily="34" charset="-122"/>
                 <a:cs typeface="Inter" pitchFamily="34" charset="-120"/>
               </a:rPr>
-              <a:t>A+B altas · C baixa</a:t>
+              <a:t>A baixa · B alta</a:t>
             </a:r>
             <a:endParaRPr lang="en-US" sz="750" dirty="0"/>
           </a:p>
@@ -23319,13 +23424,13 @@
       </p:sp>
       <p:sp>
         <p:nvSpPr>
-          <p:cNvPr id="27" name="Text 25"/>
-          <p:cNvSpPr/>
-          <p:nvPr/>
-        </p:nvSpPr>
-        <p:spPr>
-          <a:xfrm>
-            <a:off x="5146243" y="4334256"/>
+          <p:cNvPr id="30" name="Text 28"/>
+          <p:cNvSpPr/>
+          <p:nvPr/>
+        </p:nvSpPr>
+        <p:spPr>
+          <a:xfrm>
+            <a:off x="7390181" y="4334256"/>
             <a:ext cx="1896466" cy="384048"/>
           </a:xfrm>
           <a:prstGeom prst="rect">
@@ -23350,112 +23455,7 @@
                 <a:ea typeface="Fraunces" pitchFamily="34" charset="-122"/>
                 <a:cs typeface="Fraunces" pitchFamily="34" charset="-120"/>
               </a:rPr>
-              <a:t>EPP + GMO apartados</a:t>
-            </a:r>
-            <a:endParaRPr lang="en-US" sz="1100" dirty="0"/>
-          </a:p>
-        </p:txBody>
-      </p:sp>
-      <p:sp>
-        <p:nvSpPr>
-          <p:cNvPr id="28" name="Shape 26"/>
-          <p:cNvSpPr/>
-          <p:nvPr/>
-        </p:nvSpPr>
-        <p:spPr>
-          <a:xfrm>
-            <a:off x="7280453" y="3931920"/>
-            <a:ext cx="2115922" cy="841248"/>
-          </a:xfrm>
-          <a:prstGeom prst="roundRect">
-            <a:avLst>
-              <a:gd name="adj" fmla="val 6522"/>
-            </a:avLst>
-          </a:prstGeom>
-          <a:solidFill>
-            <a:srgbClr val="4A5C72"/>
-          </a:solidFill>
-          <a:ln w="9525">
-            <a:solidFill>
-              <a:srgbClr val="4A5C72"/>
-            </a:solidFill>
-            <a:prstDash val="solid"/>
-          </a:ln>
-        </p:spPr>
-      </p:sp>
-      <p:sp>
-        <p:nvSpPr>
-          <p:cNvPr id="29" name="Text 27"/>
-          <p:cNvSpPr/>
-          <p:nvPr/>
-        </p:nvSpPr>
-        <p:spPr>
-          <a:xfrm>
-            <a:off x="7390181" y="4023360"/>
-            <a:ext cx="1896466" cy="329184"/>
-          </a:xfrm>
-          <a:prstGeom prst="rect">
-            <a:avLst/>
-          </a:prstGeom>
-          <a:noFill/>
-          <a:ln/>
-        </p:spPr>
-        <p:txBody>
-          <a:bodyPr wrap="square" rtlCol="0" anchor="t"/>
-          <a:lstStyle/>
-          <a:p>
-            <a:pPr indent="0" marL="0">
-              <a:buNone/>
-            </a:pPr>
-            <a:r>
-              <a:rPr lang="en-US" sz="750" dirty="0">
-                <a:solidFill>
-                  <a:srgbClr val="B9C3D0"/>
-                </a:solidFill>
-                <a:latin typeface="Inter" pitchFamily="34" charset="0"/>
-                <a:ea typeface="Inter" pitchFamily="34" charset="-122"/>
-                <a:cs typeface="Inter" pitchFamily="34" charset="-120"/>
-              </a:rPr>
-              <a:t>A+B+C altas</a:t>
-            </a:r>
-            <a:endParaRPr lang="en-US" sz="750" dirty="0"/>
-          </a:p>
-        </p:txBody>
-      </p:sp>
-      <p:sp>
-        <p:nvSpPr>
-          <p:cNvPr id="30" name="Text 28"/>
-          <p:cNvSpPr/>
-          <p:nvPr/>
-        </p:nvSpPr>
-        <p:spPr>
-          <a:xfrm>
-            <a:off x="7390181" y="4334256"/>
-            <a:ext cx="1896466" cy="384048"/>
-          </a:xfrm>
-          <a:prstGeom prst="rect">
-            <a:avLst/>
-          </a:prstGeom>
-          <a:noFill/>
-          <a:ln/>
-        </p:spPr>
-        <p:txBody>
-          <a:bodyPr wrap="square" rtlCol="0" anchor="t"/>
-          <a:lstStyle/>
-          <a:p>
-            <a:pPr indent="0" marL="0">
-              <a:buNone/>
-            </a:pPr>
-            <a:r>
-              <a:rPr lang="en-US" sz="1100" dirty="0">
-                <a:solidFill>
-                  <a:srgbClr val="FFFDF6"/>
-                </a:solidFill>
-                <a:latin typeface="Fraunces" pitchFamily="34" charset="0"/>
-                <a:ea typeface="Fraunces" pitchFamily="34" charset="-122"/>
-                <a:cs typeface="Fraunces" pitchFamily="34" charset="-120"/>
-              </a:rPr>
-              <a:t>PM&amp;GO integrado</a:t>
+              <a:t>Sem fit → GMO</a:t>
             </a:r>
             <a:endParaRPr lang="en-US" sz="1100" dirty="0"/>
           </a:p>

</xml_diff>